<commit_message>
Regenerate all samples with updated callout colors
- PPT: sample-pt.pptx, sample-en.pptx (+ PDFs)
- Guide: main.pdf (pt + en) recompiled with XeLaTeX
- Technical: sample-report.docx (pt + en) regenerated
- Setup guide: setup-guide.pdf recompiled
</commit_message>
<xml_diff>
--- a/examples/ppt/en/sample-en.pptx
+++ b/examples/ppt/en/sample-en.pptx
@@ -8372,7 +8372,7 @@
             <a:r>
               <a:rPr sz="3600" b="1">
                 <a:solidFill>
-                  <a:srgbClr val="FFFFFF"/>
+                  <a:srgbClr val="1F2328"/>
                 </a:solidFill>
               </a:rPr>
               <a:t>Huawei Cloud Overview</a:t>
@@ -8501,7 +8501,7 @@
           <p:nvPr/>
         </p:nvGraphicFramePr>
         <p:xfrm>
-          <a:off x="731520" y="1645920"/>
+          <a:off x="1737360" y="1645920"/>
           <a:ext cx="8686800" cy="2011680"/>
         </p:xfrm>
         <a:graphic>
@@ -8863,13 +8863,8 @@
           </a:prstGeom>
           <a:noFill/>
           <a:solidFill>
-            <a:srgbClr val="D1ECF1"/>
+            <a:srgbClr val="EDF3F9"/>
           </a:solidFill>
-          <a:ln w="12700">
-            <a:solidFill>
-              <a:srgbClr val="17A2B8"/>
-            </a:solidFill>
-          </a:ln>
         </p:spPr>
         <p:txBody>
           <a:bodyPr wrap="square">
@@ -8878,17 +8873,17 @@
           <a:lstStyle/>
           <a:p>
             <a:r>
-              <a:rPr sz="1500" b="1">
+              <a:rPr sz="1400" b="1">
                 <a:solidFill>
-                  <a:srgbClr val="0C5363"/>
+                  <a:srgbClr val="1F2328"/>
                 </a:solidFill>
               </a:rPr>
               <a:t>ℹ  </a:t>
             </a:r>
             <a:r>
-              <a:rPr sz="1200" b="1">
+              <a:rPr sz="1200" b="0">
                 <a:solidFill>
-                  <a:srgbClr val="0C5363"/>
+                  <a:srgbClr val="1F2328"/>
                 </a:solidFill>
               </a:rPr>
               <a:t>The hotline needs to know the official service name for SR routing.</a:t>
@@ -8956,13 +8951,8 @@
           </a:prstGeom>
           <a:noFill/>
           <a:solidFill>
-            <a:srgbClr val="FFF3CD"/>
+            <a:srgbClr val="FDF8EE"/>
           </a:solidFill>
-          <a:ln w="12700">
-            <a:solidFill>
-              <a:srgbClr val="FFC107"/>
-            </a:solidFill>
-          </a:ln>
         </p:spPr>
         <p:txBody>
           <a:bodyPr wrap="square">
@@ -8971,17 +8961,17 @@
           <a:lstStyle/>
           <a:p>
             <a:r>
-              <a:rPr sz="1500" b="1">
+              <a:rPr sz="1400" b="1">
                 <a:solidFill>
-                  <a:srgbClr val="896B00"/>
+                  <a:srgbClr val="1F2328"/>
                 </a:solidFill>
               </a:rPr>
               <a:t>⚠  </a:t>
             </a:r>
             <a:r>
-              <a:rPr sz="1200" b="1">
+              <a:rPr sz="1200" b="0">
                 <a:solidFill>
-                  <a:srgbClr val="896B00"/>
+                  <a:srgbClr val="1F2328"/>
                 </a:solidFill>
               </a:rPr>
               <a:t>Never ask for or accept credentials. Guide the customer to self-service.</a:t>
@@ -9005,13 +8995,8 @@
           </a:prstGeom>
           <a:noFill/>
           <a:solidFill>
-            <a:srgbClr val="D4EDDA"/>
+            <a:srgbClr val="EDF6ED"/>
           </a:solidFill>
-          <a:ln w="12700">
-            <a:solidFill>
-              <a:srgbClr val="28A745"/>
-            </a:solidFill>
-          </a:ln>
         </p:spPr>
         <p:txBody>
           <a:bodyPr wrap="square">
@@ -9020,17 +9005,17 @@
           <a:lstStyle/>
           <a:p>
             <a:r>
-              <a:rPr sz="1500" b="1">
+              <a:rPr sz="1400" b="1">
                 <a:solidFill>
-                  <a:srgbClr val="155724"/>
+                  <a:srgbClr val="1F2328"/>
                 </a:solidFill>
               </a:rPr>
               <a:t>✓  </a:t>
             </a:r>
             <a:r>
-              <a:rPr sz="1200" b="1">
+              <a:rPr sz="1200" b="0">
                 <a:solidFill>
-                  <a:srgbClr val="155724"/>
+                  <a:srgbClr val="1F2328"/>
                 </a:solidFill>
               </a:rPr>
               <a:t>Always validate the caller identity against the authorized contact list.</a:t>
@@ -9054,13 +9039,8 @@
           </a:prstGeom>
           <a:noFill/>
           <a:solidFill>
-            <a:srgbClr val="D1ECF1"/>
+            <a:srgbClr val="EDF3F9"/>
           </a:solidFill>
-          <a:ln w="12700">
-            <a:solidFill>
-              <a:srgbClr val="17A2B8"/>
-            </a:solidFill>
-          </a:ln>
         </p:spPr>
         <p:txBody>
           <a:bodyPr wrap="square">
@@ -9069,17 +9049,17 @@
           <a:lstStyle/>
           <a:p>
             <a:r>
-              <a:rPr sz="1500" b="1">
+              <a:rPr sz="1400" b="1">
                 <a:solidFill>
-                  <a:srgbClr val="0C5363"/>
+                  <a:srgbClr val="1F2328"/>
                 </a:solidFill>
               </a:rPr>
               <a:t>ℹ  </a:t>
             </a:r>
             <a:r>
-              <a:rPr sz="1200" b="1">
+              <a:rPr sz="1200" b="0">
                 <a:solidFill>
-                  <a:srgbClr val="0C5363"/>
+                  <a:srgbClr val="1F2328"/>
                 </a:solidFill>
               </a:rPr>
               <a:t>ManageOne is the operations platform, not a cloud service itself.</a:t>

</xml_diff>